<commit_message>
Updated material for lecture 7.2
</commit_message>
<xml_diff>
--- a/Module 7/class_7.2/deep_learning_course_class_7.2.pptx
+++ b/Module 7/class_7.2/deep_learning_course_class_7.2.pptx
@@ -1204,7 +1204,7 @@
   <p:cSld>
     <p:spTree>
       <p:nvGrpSpPr>
-        <p:cNvPr id="151" name="Shape 151"/>
+        <p:cNvPr id="152" name="Shape 152"/>
         <p:cNvGrpSpPr/>
         <p:nvPr/>
       </p:nvGrpSpPr>
@@ -1218,7 +1218,7 @@
       </p:grpSpPr>
       <p:sp>
         <p:nvSpPr>
-          <p:cNvPr id="152" name="Google Shape;152;g3ed59dca7d7_0_54:notes"/>
+          <p:cNvPr id="153" name="Google Shape;153;g3ed59dca7d7_0_54:notes"/>
           <p:cNvSpPr/>
           <p:nvPr>
             <p:ph idx="2" type="sldImg"/>
@@ -1253,7 +1253,7 @@
       </p:sp>
       <p:sp>
         <p:nvSpPr>
-          <p:cNvPr id="153" name="Google Shape;153;g3ed59dca7d7_0_54:notes"/>
+          <p:cNvPr id="154" name="Google Shape;154;g3ed59dca7d7_0_54:notes"/>
           <p:cNvSpPr txBox="1"/>
           <p:nvPr>
             <p:ph idx="1" type="body"/>
@@ -1303,7 +1303,7 @@
   <p:cSld>
     <p:spTree>
       <p:nvGrpSpPr>
-        <p:cNvPr id="158" name="Shape 158"/>
+        <p:cNvPr id="159" name="Shape 159"/>
         <p:cNvGrpSpPr/>
         <p:nvPr/>
       </p:nvGrpSpPr>
@@ -1317,7 +1317,7 @@
       </p:grpSpPr>
       <p:sp>
         <p:nvSpPr>
-          <p:cNvPr id="159" name="Google Shape;159;g3ed59dca7d7_0_42:notes"/>
+          <p:cNvPr id="160" name="Google Shape;160;g3ed59dca7d7_0_42:notes"/>
           <p:cNvSpPr/>
           <p:nvPr>
             <p:ph idx="2" type="sldImg"/>
@@ -1352,7 +1352,7 @@
       </p:sp>
       <p:sp>
         <p:nvSpPr>
-          <p:cNvPr id="160" name="Google Shape;160;g3ed59dca7d7_0_42:notes"/>
+          <p:cNvPr id="161" name="Google Shape;161;g3ed59dca7d7_0_42:notes"/>
           <p:cNvSpPr txBox="1"/>
           <p:nvPr>
             <p:ph idx="1" type="body"/>
@@ -1402,7 +1402,7 @@
   <p:cSld>
     <p:spTree>
       <p:nvGrpSpPr>
-        <p:cNvPr id="166" name="Shape 166"/>
+        <p:cNvPr id="167" name="Shape 167"/>
         <p:cNvGrpSpPr/>
         <p:nvPr/>
       </p:nvGrpSpPr>
@@ -1416,7 +1416,7 @@
       </p:grpSpPr>
       <p:sp>
         <p:nvSpPr>
-          <p:cNvPr id="167" name="Google Shape;167;g3ed59dca7d7_0_68:notes"/>
+          <p:cNvPr id="168" name="Google Shape;168;g3ed59dca7d7_0_68:notes"/>
           <p:cNvSpPr/>
           <p:nvPr>
             <p:ph idx="2" type="sldImg"/>
@@ -1451,7 +1451,7 @@
       </p:sp>
       <p:sp>
         <p:nvSpPr>
-          <p:cNvPr id="168" name="Google Shape;168;g3ed59dca7d7_0_68:notes"/>
+          <p:cNvPr id="169" name="Google Shape;169;g3ed59dca7d7_0_68:notes"/>
           <p:cNvSpPr txBox="1"/>
           <p:nvPr>
             <p:ph idx="1" type="body"/>
@@ -1501,7 +1501,7 @@
   <p:cSld>
     <p:spTree>
       <p:nvGrpSpPr>
-        <p:cNvPr id="173" name="Shape 173"/>
+        <p:cNvPr id="174" name="Shape 174"/>
         <p:cNvGrpSpPr/>
         <p:nvPr/>
       </p:nvGrpSpPr>
@@ -1515,7 +1515,7 @@
       </p:grpSpPr>
       <p:sp>
         <p:nvSpPr>
-          <p:cNvPr id="174" name="Google Shape;174;g3ed59dca7d7_0_75:notes"/>
+          <p:cNvPr id="175" name="Google Shape;175;g3ed59dca7d7_0_75:notes"/>
           <p:cNvSpPr/>
           <p:nvPr>
             <p:ph idx="2" type="sldImg"/>
@@ -1550,7 +1550,7 @@
       </p:sp>
       <p:sp>
         <p:nvSpPr>
-          <p:cNvPr id="175" name="Google Shape;175;g3ed59dca7d7_0_75:notes"/>
+          <p:cNvPr id="176" name="Google Shape;176;g3ed59dca7d7_0_75:notes"/>
           <p:cNvSpPr txBox="1"/>
           <p:nvPr>
             <p:ph idx="1" type="body"/>
@@ -1600,7 +1600,7 @@
   <p:cSld>
     <p:spTree>
       <p:nvGrpSpPr>
-        <p:cNvPr id="179" name="Shape 179"/>
+        <p:cNvPr id="181" name="Shape 181"/>
         <p:cNvGrpSpPr/>
         <p:nvPr/>
       </p:nvGrpSpPr>
@@ -1614,7 +1614,7 @@
       </p:grpSpPr>
       <p:sp>
         <p:nvSpPr>
-          <p:cNvPr id="180" name="Google Shape;180;g3eb9223848a_0_5:notes"/>
+          <p:cNvPr id="182" name="Google Shape;182;g3eb9223848a_0_5:notes"/>
           <p:cNvSpPr/>
           <p:nvPr>
             <p:ph idx="2" type="sldImg"/>
@@ -1649,7 +1649,7 @@
       </p:sp>
       <p:sp>
         <p:nvSpPr>
-          <p:cNvPr id="181" name="Google Shape;181;g3eb9223848a_0_5:notes"/>
+          <p:cNvPr id="183" name="Google Shape;183;g3eb9223848a_0_5:notes"/>
           <p:cNvSpPr txBox="1"/>
           <p:nvPr>
             <p:ph idx="1" type="body"/>
@@ -1699,7 +1699,7 @@
   <p:cSld>
     <p:spTree>
       <p:nvGrpSpPr>
-        <p:cNvPr id="186" name="Shape 186"/>
+        <p:cNvPr id="188" name="Shape 188"/>
         <p:cNvGrpSpPr/>
         <p:nvPr/>
       </p:nvGrpSpPr>
@@ -1713,7 +1713,7 @@
       </p:grpSpPr>
       <p:sp>
         <p:nvSpPr>
-          <p:cNvPr id="187" name="Google Shape;187;g3e82c63d41f_0_43:notes"/>
+          <p:cNvPr id="189" name="Google Shape;189;g3e82c63d41f_0_43:notes"/>
           <p:cNvSpPr/>
           <p:nvPr>
             <p:ph idx="2" type="sldImg"/>
@@ -1748,7 +1748,7 @@
       </p:sp>
       <p:sp>
         <p:nvSpPr>
-          <p:cNvPr id="188" name="Google Shape;188;g3e82c63d41f_0_43:notes"/>
+          <p:cNvPr id="190" name="Google Shape;190;g3e82c63d41f_0_43:notes"/>
           <p:cNvSpPr txBox="1"/>
           <p:nvPr>
             <p:ph idx="1" type="body"/>
@@ -8539,6 +8539,56 @@
           </a:p>
         </p:txBody>
       </p:sp>
+      <p:sp>
+        <p:nvSpPr>
+          <p:cNvPr id="151" name="Google Shape;151;p25"/>
+          <p:cNvSpPr txBox="1"/>
+          <p:nvPr/>
+        </p:nvSpPr>
+        <p:spPr>
+          <a:xfrm>
+            <a:off x="6692100" y="4755100"/>
+            <a:ext cx="2450400" cy="369300"/>
+          </a:xfrm>
+          <a:prstGeom prst="rect">
+            <a:avLst/>
+          </a:prstGeom>
+          <a:noFill/>
+          <a:ln>
+            <a:noFill/>
+          </a:ln>
+        </p:spPr>
+        <p:txBody>
+          <a:bodyPr anchorCtr="0" anchor="t" bIns="91425" lIns="91425" spcFirstLastPara="1" rIns="91425" wrap="square" tIns="91425">
+            <a:spAutoFit/>
+          </a:bodyPr>
+          <a:lstStyle/>
+          <a:p>
+            <a:pPr indent="0" lvl="0" marL="0" rtl="0" algn="l">
+              <a:spcBef>
+                <a:spcPts val="0"/>
+              </a:spcBef>
+              <a:spcAft>
+                <a:spcPts val="0"/>
+              </a:spcAft>
+              <a:buNone/>
+            </a:pPr>
+            <a:r>
+              <a:rPr lang="en" sz="1200">
+                <a:solidFill>
+                  <a:schemeClr val="dk2"/>
+                </a:solidFill>
+              </a:rPr>
+              <a:t>value_iteration.py</a:t>
+            </a:r>
+            <a:endParaRPr sz="1200">
+              <a:solidFill>
+                <a:schemeClr val="dk2"/>
+              </a:solidFill>
+            </a:endParaRPr>
+          </a:p>
+        </p:txBody>
+      </p:sp>
     </p:spTree>
   </p:cSld>
   <p:clrMapOvr>
@@ -8552,7 +8602,7 @@
   <p:cSld>
     <p:spTree>
       <p:nvGrpSpPr>
-        <p:cNvPr id="154" name="Shape 154"/>
+        <p:cNvPr id="155" name="Shape 155"/>
         <p:cNvGrpSpPr/>
         <p:nvPr/>
       </p:nvGrpSpPr>
@@ -8566,7 +8616,7 @@
       </p:grpSpPr>
       <p:sp>
         <p:nvSpPr>
-          <p:cNvPr id="155" name="Google Shape;155;p26"/>
+          <p:cNvPr id="156" name="Google Shape;156;p26"/>
           <p:cNvSpPr txBox="1"/>
           <p:nvPr>
             <p:ph type="title"/>
@@ -8626,7 +8676,7 @@
       </p:sp>
       <p:sp>
         <p:nvSpPr>
-          <p:cNvPr id="156" name="Google Shape;156;p26"/>
+          <p:cNvPr id="157" name="Google Shape;157;p26"/>
           <p:cNvSpPr txBox="1"/>
           <p:nvPr>
             <p:ph idx="1" type="body"/>
@@ -8708,7 +8758,7 @@
       </p:sp>
       <p:sp>
         <p:nvSpPr>
-          <p:cNvPr id="157" name="Google Shape;157;p26"/>
+          <p:cNvPr id="158" name="Google Shape;158;p26"/>
           <p:cNvSpPr txBox="1"/>
           <p:nvPr/>
         </p:nvSpPr>
@@ -8873,7 +8923,7 @@
   <p:cSld>
     <p:spTree>
       <p:nvGrpSpPr>
-        <p:cNvPr id="161" name="Shape 161"/>
+        <p:cNvPr id="162" name="Shape 162"/>
         <p:cNvGrpSpPr/>
         <p:nvPr/>
       </p:nvGrpSpPr>
@@ -8887,7 +8937,7 @@
       </p:grpSpPr>
       <p:sp>
         <p:nvSpPr>
-          <p:cNvPr id="162" name="Google Shape;162;p27"/>
+          <p:cNvPr id="163" name="Google Shape;163;p27"/>
           <p:cNvSpPr txBox="1"/>
           <p:nvPr>
             <p:ph type="title"/>
@@ -8927,7 +8977,7 @@
       </p:sp>
       <p:sp>
         <p:nvSpPr>
-          <p:cNvPr id="163" name="Google Shape;163;p27"/>
+          <p:cNvPr id="164" name="Google Shape;164;p27"/>
           <p:cNvSpPr txBox="1"/>
           <p:nvPr/>
         </p:nvSpPr>
@@ -9017,7 +9067,7 @@
       </p:sp>
       <p:pic>
         <p:nvPicPr>
-          <p:cNvPr descr="{&quot;backgroundColorModified&quot;:false,&quot;code&quot;:&quot;\\begin{gather*}\n{\\text{Optimal}\\;\\text{value}\\;\\text{function:}\\;\\text{best}\\;\\text{achievable}\\;\\text{expected}\\;\\text{return}\\;\\text{at}\\;\\text{state}\\;\\text{s}}\\\\\n{V^{\\star}\\left(s\\right)=\\max_{\\pi}\\left(V^{\\pi}\\left(s\\right)\\right)}\\\\\n{\\text{Optimal}\\;\\text{Q}\\;\\text{function}:\\,\\text{best}\\;\\text{achievable}\\;\\text{expected}\\;\\text{return}\\;\\text{from}\\;\\text{state}\\;\\text{s}\\;\\text{after}\\;\\text{taking}\\;\\text{action}\\;\\text{a}\\text{}}\\\\\n{Q^{\\star}\\left(s,a\\right)=\\max_{\\pi}\\left(Q^{\\pi}\\left(s,a\\right)\\right)}\\\\\n{\\text{Optimal}\\;V\\,\\text{satisfies:}}\\\\\n{V^{\\star}\\left(s\\right)=\\max_{a}\\left(\\sum_{s^{\\prime}}^{}P\\left(\\giventhat{s^{\\prime}}{s,a}\\right)\\left[r\\left(s,a\\right)+\\gamma V^{\\star}\\left(s^{\\prime}\\right)\\right]\\right)}\\\\\n{\\text{which}\\;\\text{translates}\\;\\text{into}\\;\\text{the}\\;\\text{recursion}}\\\\\n{V_{k+1}^{\\star}\\left(s\\right)=\\max_{a}\\left(\\sum_{s^{\\prime}}^{}P\\left(\\giventhat{s^{\\prime}}{s,a}\\right)\\left[r\\left(s,a\\right)+\\gamma V_{k}^{\\star}\\left(s^{\\prime}\\right)\\right]\\right)}\\\\\n{\\text{starting}\\;\\text{with:}}\\\\\n{V_{0}\\left(s\\right)=0}\t\n\\end{gather*}&quot;,&quot;id&quot;:&quot;5&quot;,&quot;aid&quot;:null,&quot;backgroundColor&quot;:&quot;#FFFFFF&quot;,&quot;type&quot;:&quot;gather*&quot;,&quot;font&quot;:{&quot;color&quot;:&quot;#000000&quot;,&quot;family&quot;:&quot;Arial&quot;,&quot;size&quot;:12},&quot;ts&quot;:1781221693436,&quot;cs&quot;:&quot;80VyhHXu/rDidpk68cQ+Yg==&quot;,&quot;size&quot;:{&quot;width&quot;:705.5,&quot;height&quot;:331}}" id="164" name="Google Shape;164;p27"/>
+          <p:cNvPr descr="{&quot;backgroundColorModified&quot;:false,&quot;code&quot;:&quot;\\begin{gather*}\n{\\text{Optimal}\\;\\text{value}\\;\\text{function:}\\;\\text{best}\\;\\text{achievable}\\;\\text{expected}\\;\\text{return}\\;\\text{at}\\;\\text{state}\\;\\text{s}}\\\\\n{V^{\\star}\\left(s\\right)=\\max_{\\pi}\\left(V^{\\pi}\\left(s\\right)\\right)}\\\\\n{\\text{Optimal}\\;\\text{Q}\\;\\text{function}:\\,\\text{best}\\;\\text{achievable}\\;\\text{expected}\\;\\text{return}\\;\\text{from}\\;\\text{state}\\;\\text{s}\\;\\text{after}\\;\\text{taking}\\;\\text{action}\\;\\text{a}\\text{}}\\\\\n{Q^{\\star}\\left(s,a\\right)=\\max_{\\pi}\\left(Q^{\\pi}\\left(s,a\\right)\\right)}\\\\\n{\\text{Optimal}\\;V\\,\\text{satisfies:}}\\\\\n{V^{\\star}\\left(s\\right)=\\max_{a}\\left(\\sum_{s^{\\prime}}^{}P\\left(\\giventhat{s^{\\prime}}{s,a}\\right)\\left[r\\left(s,a\\right)+\\gamma V^{\\star}\\left(s^{\\prime}\\right)\\right]\\right)}\\\\\n{\\text{which}\\;\\text{translates}\\;\\text{into}\\;\\text{the}\\;\\text{recursion}}\\\\\n{V_{k+1}^{\\star}\\left(s\\right)=\\max_{a}\\left(\\sum_{s^{\\prime}}^{}P\\left(\\giventhat{s^{\\prime}}{s,a}\\right)\\left[r\\left(s,a\\right)+\\gamma V_{k}^{\\star}\\left(s^{\\prime}\\right)\\right]\\right)}\\\\\n{\\text{starting}\\;\\text{with:}}\\\\\n{V_{0}\\left(s\\right)=0}\t\n\\end{gather*}&quot;,&quot;id&quot;:&quot;5&quot;,&quot;aid&quot;:null,&quot;backgroundColor&quot;:&quot;#FFFFFF&quot;,&quot;type&quot;:&quot;gather*&quot;,&quot;font&quot;:{&quot;color&quot;:&quot;#000000&quot;,&quot;family&quot;:&quot;Arial&quot;,&quot;size&quot;:12},&quot;ts&quot;:1781221693436,&quot;cs&quot;:&quot;80VyhHXu/rDidpk68cQ+Yg==&quot;,&quot;size&quot;:{&quot;width&quot;:705.5,&quot;height&quot;:331}}" id="165" name="Google Shape;165;p27"/>
           <p:cNvPicPr preferRelativeResize="0"/>
           <p:nvPr/>
         </p:nvPicPr>
@@ -9045,7 +9095,7 @@
       </p:pic>
       <p:sp>
         <p:nvSpPr>
-          <p:cNvPr id="165" name="Google Shape;165;p27"/>
+          <p:cNvPr id="166" name="Google Shape;166;p27"/>
           <p:cNvSpPr txBox="1"/>
           <p:nvPr/>
         </p:nvSpPr>
@@ -9106,7 +9156,7 @@
   <p:cSld>
     <p:spTree>
       <p:nvGrpSpPr>
-        <p:cNvPr id="169" name="Shape 169"/>
+        <p:cNvPr id="170" name="Shape 170"/>
         <p:cNvGrpSpPr/>
         <p:nvPr/>
       </p:nvGrpSpPr>
@@ -9120,7 +9170,7 @@
       </p:grpSpPr>
       <p:sp>
         <p:nvSpPr>
-          <p:cNvPr id="170" name="Google Shape;170;p28"/>
+          <p:cNvPr id="171" name="Google Shape;171;p28"/>
           <p:cNvSpPr txBox="1"/>
           <p:nvPr>
             <p:ph type="title"/>
@@ -9160,7 +9210,7 @@
       </p:sp>
       <p:sp>
         <p:nvSpPr>
-          <p:cNvPr id="171" name="Google Shape;171;p28"/>
+          <p:cNvPr id="172" name="Google Shape;172;p28"/>
           <p:cNvSpPr txBox="1"/>
           <p:nvPr/>
         </p:nvSpPr>
@@ -9234,7 +9284,7 @@
       </p:sp>
       <p:pic>
         <p:nvPicPr>
-          <p:cNvPr descr="{&quot;font&quot;:{&quot;size&quot;:12,&quot;family&quot;:&quot;Arial&quot;,&quot;color&quot;:&quot;#000000&quot;},&quot;aid&quot;:null,&quot;backgroundColorModified&quot;:false,&quot;type&quot;:&quot;gather*&quot;,&quot;backgroundColor&quot;:&quot;#FFFFFF&quot;,&quot;id&quot;:&quot;5&quot;,&quot;code&quot;:&quot;\\begin{gather*}\n{\\text{Optimal}\\;\\text{policy}\\;\\text{is}\\;\\text{the}\\;\\text{greedy}\\;\\text{policy}}\\\\\n{\\pi^{\\star}\\left(s\\right)=\\arg\\,\\max_{a}\\left(\\sum_{s^{\\prime}}^{}P\\left(\\giventhat{s^{\\prime}}{s,a}\\right)\\left[r\\left(s,a\\right)+\\gamma V_{k}^{\\star}\\left(s^{\\prime}\\right)\\right]\\right)}\t\n\\end{gather*}&quot;,&quot;ts&quot;:1781178096334,&quot;cs&quot;:&quot;MFvO9e5HjSzIg1cIAU313Q==&quot;,&quot;size&quot;:{&quot;width&quot;:447.6666666666667,&quot;height&quot;:80}}" id="172" name="Google Shape;172;p28"/>
+          <p:cNvPr descr="{&quot;font&quot;:{&quot;size&quot;:12,&quot;family&quot;:&quot;Arial&quot;,&quot;color&quot;:&quot;#000000&quot;},&quot;aid&quot;:null,&quot;backgroundColorModified&quot;:false,&quot;type&quot;:&quot;gather*&quot;,&quot;backgroundColor&quot;:&quot;#FFFFFF&quot;,&quot;id&quot;:&quot;5&quot;,&quot;code&quot;:&quot;\\begin{gather*}\n{\\text{Optimal}\\;\\text{policy}\\;\\text{is}\\;\\text{the}\\;\\text{greedy}\\;\\text{policy}}\\\\\n{\\pi^{\\star}\\left(s\\right)=\\arg\\,\\max_{a}\\left(\\sum_{s^{\\prime}}^{}P\\left(\\giventhat{s^{\\prime}}{s,a}\\right)\\left[r\\left(s,a\\right)+\\gamma V_{k}^{\\star}\\left(s^{\\prime}\\right)\\right]\\right)}\t\n\\end{gather*}&quot;,&quot;ts&quot;:1781178096334,&quot;cs&quot;:&quot;MFvO9e5HjSzIg1cIAU313Q==&quot;,&quot;size&quot;:{&quot;width&quot;:447.6666666666667,&quot;height&quot;:80}}" id="173" name="Google Shape;173;p28"/>
           <p:cNvPicPr preferRelativeResize="0"/>
           <p:nvPr/>
         </p:nvPicPr>
@@ -9273,7 +9323,7 @@
   <p:cSld>
     <p:spTree>
       <p:nvGrpSpPr>
-        <p:cNvPr id="176" name="Shape 176"/>
+        <p:cNvPr id="177" name="Shape 177"/>
         <p:cNvGrpSpPr/>
         <p:nvPr/>
       </p:nvGrpSpPr>
@@ -9287,7 +9337,7 @@
       </p:grpSpPr>
       <p:sp>
         <p:nvSpPr>
-          <p:cNvPr id="177" name="Google Shape;177;p29"/>
+          <p:cNvPr id="178" name="Google Shape;178;p29"/>
           <p:cNvSpPr txBox="1"/>
           <p:nvPr>
             <p:ph type="title"/>
@@ -9327,7 +9377,7 @@
       </p:sp>
       <p:sp>
         <p:nvSpPr>
-          <p:cNvPr id="178" name="Google Shape;178;p29"/>
+          <p:cNvPr id="179" name="Google Shape;179;p29"/>
           <p:cNvSpPr txBox="1"/>
           <p:nvPr>
             <p:ph idx="1" type="body"/>
@@ -9534,6 +9584,56 @@
               <a:t>  U    R    U    L </a:t>
             </a:r>
             <a:endParaRPr/>
+          </a:p>
+        </p:txBody>
+      </p:sp>
+      <p:sp>
+        <p:nvSpPr>
+          <p:cNvPr id="180" name="Google Shape;180;p29"/>
+          <p:cNvSpPr txBox="1"/>
+          <p:nvPr/>
+        </p:nvSpPr>
+        <p:spPr>
+          <a:xfrm>
+            <a:off x="421200" y="4610425"/>
+            <a:ext cx="4360800" cy="415500"/>
+          </a:xfrm>
+          <a:prstGeom prst="rect">
+            <a:avLst/>
+          </a:prstGeom>
+          <a:noFill/>
+          <a:ln>
+            <a:noFill/>
+          </a:ln>
+        </p:spPr>
+        <p:txBody>
+          <a:bodyPr anchorCtr="0" anchor="t" bIns="91425" lIns="91425" spcFirstLastPara="1" rIns="91425" wrap="square" tIns="91425">
+            <a:spAutoFit/>
+          </a:bodyPr>
+          <a:lstStyle/>
+          <a:p>
+            <a:pPr indent="0" lvl="0" marL="0" rtl="0" algn="l">
+              <a:spcBef>
+                <a:spcPts val="0"/>
+              </a:spcBef>
+              <a:spcAft>
+                <a:spcPts val="0"/>
+              </a:spcAft>
+              <a:buNone/>
+            </a:pPr>
+            <a:r>
+              <a:rPr lang="en" sz="1500">
+                <a:solidFill>
+                  <a:schemeClr val="dk2"/>
+                </a:solidFill>
+              </a:rPr>
+              <a:t>optimal_policy_iteration.py</a:t>
+            </a:r>
+            <a:endParaRPr sz="1500">
+              <a:solidFill>
+                <a:schemeClr val="dk2"/>
+              </a:solidFill>
+            </a:endParaRPr>
           </a:p>
         </p:txBody>
       </p:sp>
@@ -9550,7 +9650,7 @@
   <p:cSld>
     <p:spTree>
       <p:nvGrpSpPr>
-        <p:cNvPr id="182" name="Shape 182"/>
+        <p:cNvPr id="184" name="Shape 184"/>
         <p:cNvGrpSpPr/>
         <p:nvPr/>
       </p:nvGrpSpPr>
@@ -9564,7 +9664,7 @@
       </p:grpSpPr>
       <p:sp>
         <p:nvSpPr>
-          <p:cNvPr id="183" name="Google Shape;183;p30"/>
+          <p:cNvPr id="185" name="Google Shape;185;p30"/>
           <p:cNvSpPr txBox="1"/>
           <p:nvPr>
             <p:ph type="title"/>
@@ -9604,7 +9704,7 @@
       </p:sp>
       <p:sp>
         <p:nvSpPr>
-          <p:cNvPr id="184" name="Google Shape;184;p30"/>
+          <p:cNvPr id="186" name="Google Shape;186;p30"/>
           <p:cNvSpPr txBox="1"/>
           <p:nvPr/>
         </p:nvSpPr>
@@ -9678,7 +9778,7 @@
       </p:sp>
       <p:pic>
         <p:nvPicPr>
-          <p:cNvPr descr="{&quot;type&quot;:&quot;gather*&quot;,&quot;font&quot;:{&quot;color&quot;:&quot;#000000&quot;,&quot;family&quot;:&quot;Arial&quot;,&quot;size&quot;:12},&quot;backgroundColor&quot;:&quot;#FFFFFF&quot;,&quot;code&quot;:&quot;\\begin{gather*}\n{\\text{Optimal}\\;\\text{Q}\\;\\text{function}:\\,\\text{best}\\;\\text{achievable}\\;\\text{expected}\\;\\text{return}\\;\\text{from}\\;\\text{state}\\;\\text{s}\\;\\text{after}\\;\\text{taking}\\;\\text{action}\\;\\text{a}\\text{}}\\\\\n{Q^{\\star}\\left(s,a\\right)=\\max_{\\pi}\\left(Q^{\\pi}\\left(s,a\\right)\\right)}\\\\\n{\\text{The}\\;\\text{optimal}\\;\\text{Q}\\;\\text{function}\\;\\text{satisfies:}}\\\\\n{Q^{\\star}\\left(s,a\\right)=\\sum_{s^{\\prime}}^{}P\\left(\\giventhat{s^{\\prime}}{s,a}\\right)\\left[r\\left(s,a\\right)+\\gamma \\arg \\,\\max_{a^{\\prime}}\\left(Q^{\\star}\\left(s^{\\prime},a^{\\prime}\\right)\\right)\\right]}\\\\\n{\\text{Intuition:}\\;\\text{The}\\;\\text{immediate}\\;\\text{value}\\;\\text{of}\\;\\text{taking}\\;\\text{an}\\;\\text{action}\\;\\text{in}\\;\\text{state}\\;\\text{s}}\\\\\n{=\\text{immediate}\\;\\text{reward}\\;\\text{+}\\;\\text{discount}\\text{ed}\\;\\text{value}\\;\\text{of}\\;\\text{best}\\;\\text{action}\\;\\text{in}\\;\\text{the}\\;\\text{next}\\;\\text{state}}\\\\\n{\\text{This}\\;\\text{translates}\\;\\text{into}\\;\\text{the}\\;\\text{recursion:}}\\\\\n{Q_{k+1}^{\\star}\\left(s,a\\right)=\\sum_{s^{\\prime}}^{}P\\left(\\giventhat{s^{\\prime}}{s,a}\\right)\\left[r\\left(s,a\\right)+\\gamma \\arg \\,\\max_{a^{\\prime}}\\left(Q_{k}^{\\star}\\left(s^{\\prime},a^{\\prime}\\right)\\right)\\right]}\\\\\n{\\text{Now}\\;\\text{the}\\;\\text{optimal}\\;\\text{policy}\\;\\text{is}\\;\\text{simply:}}\\\\\n{\\arg \\max_{a}\\left(Q^{\\star}\\left(s,a\\right)\\right)}\t\n\\end{gather*}&quot;,&quot;backgroundColorModified&quot;:false,&quot;id&quot;:&quot;5&quot;,&quot;aid&quot;:null,&quot;ts&quot;:1781221535337,&quot;cs&quot;:&quot;zt+iuxtjphC+AUT2ZcHHQw==&quot;,&quot;size&quot;:{&quot;width&quot;:705.5,&quot;height&quot;:316.5}}" id="185" name="Google Shape;185;p30"/>
+          <p:cNvPr descr="{&quot;type&quot;:&quot;gather*&quot;,&quot;font&quot;:{&quot;color&quot;:&quot;#000000&quot;,&quot;family&quot;:&quot;Arial&quot;,&quot;size&quot;:12},&quot;backgroundColor&quot;:&quot;#FFFFFF&quot;,&quot;code&quot;:&quot;\\begin{gather*}\n{\\text{Optimal}\\;\\text{Q}\\;\\text{function}:\\,\\text{best}\\;\\text{achievable}\\;\\text{expected}\\;\\text{return}\\;\\text{from}\\;\\text{state}\\;\\text{s}\\;\\text{after}\\;\\text{taking}\\;\\text{action}\\;\\text{a}\\text{}}\\\\\n{Q^{\\star}\\left(s,a\\right)=\\max_{\\pi}\\left(Q^{\\pi}\\left(s,a\\right)\\right)}\\\\\n{\\text{The}\\;\\text{optimal}\\;\\text{Q}\\;\\text{function}\\;\\text{satisfies:}}\\\\\n{Q^{\\star}\\left(s,a\\right)=\\sum_{s^{\\prime}}^{}P\\left(\\giventhat{s^{\\prime}}{s,a}\\right)\\left[r\\left(s,a\\right)+\\gamma \\arg \\,\\max_{a^{\\prime}}\\left(Q^{\\star}\\left(s^{\\prime},a^{\\prime}\\right)\\right)\\right]}\\\\\n{\\text{Intuition:}\\;\\text{The}\\;\\text{immediate}\\;\\text{value}\\;\\text{of}\\;\\text{taking}\\;\\text{an}\\;\\text{action}\\;\\text{in}\\;\\text{state}\\;\\text{s}}\\\\\n{=\\text{immediate}\\;\\text{reward}\\;\\text{+}\\;\\text{discount}\\text{ed}\\;\\text{value}\\;\\text{of}\\;\\text{best}\\;\\text{action}\\;\\text{in}\\;\\text{the}\\;\\text{next}\\;\\text{state}}\\\\\n{\\text{This}\\;\\text{translates}\\;\\text{into}\\;\\text{the}\\;\\text{recursion:}}\\\\\n{Q_{k+1}^{\\star}\\left(s,a\\right)=\\sum_{s^{\\prime}}^{}P\\left(\\giventhat{s^{\\prime}}{s,a}\\right)\\left[r\\left(s,a\\right)+\\gamma \\arg \\,\\max_{a^{\\prime}}\\left(Q_{k}^{\\star}\\left(s^{\\prime},a^{\\prime}\\right)\\right)\\right]}\\\\\n{\\text{Now}\\;\\text{the}\\;\\text{optimal}\\;\\text{policy}\\;\\text{is}\\;\\text{simply:}}\\\\\n{\\arg \\max_{a}\\left(Q^{\\star}\\left(s,a\\right)\\right)}\t\n\\end{gather*}&quot;,&quot;backgroundColorModified&quot;:false,&quot;id&quot;:&quot;5&quot;,&quot;aid&quot;:null,&quot;ts&quot;:1781221535337,&quot;cs&quot;:&quot;zt+iuxtjphC+AUT2ZcHHQw==&quot;,&quot;size&quot;:{&quot;width&quot;:705.5,&quot;height&quot;:316.5}}" id="187" name="Google Shape;187;p30"/>
           <p:cNvPicPr preferRelativeResize="0"/>
           <p:nvPr/>
         </p:nvPicPr>
@@ -9717,7 +9817,7 @@
   <p:cSld>
     <p:spTree>
       <p:nvGrpSpPr>
-        <p:cNvPr id="189" name="Shape 189"/>
+        <p:cNvPr id="191" name="Shape 191"/>
         <p:cNvGrpSpPr/>
         <p:nvPr/>
       </p:nvGrpSpPr>
@@ -9731,7 +9831,7 @@
       </p:grpSpPr>
       <p:sp>
         <p:nvSpPr>
-          <p:cNvPr id="190" name="Google Shape;190;p31"/>
+          <p:cNvPr id="192" name="Google Shape;192;p31"/>
           <p:cNvSpPr txBox="1"/>
           <p:nvPr>
             <p:ph type="title"/>
@@ -9771,7 +9871,7 @@
       </p:sp>
       <p:sp>
         <p:nvSpPr>
-          <p:cNvPr id="191" name="Google Shape;191;p31"/>
+          <p:cNvPr id="193" name="Google Shape;193;p31"/>
           <p:cNvSpPr txBox="1"/>
           <p:nvPr>
             <p:ph idx="1" type="body"/>
@@ -9838,7 +9938,7 @@
             </a:pPr>
             <a:r>
               <a:rPr lang="en"/>
-              <a:t>Add stochastic transition: Modify value iteration so that intended actions succeed with probability 0.8 and slip sideways with probability 0.1 each.</a:t>
+              <a:t>Add stochastic transition: Modify value iteration so that intended actions succeed with probability 0.8 and slip sideways with probability 0.1 each (see optimal_policy_iteration_stochastic.py)</a:t>
             </a:r>
             <a:endParaRPr/>
           </a:p>
@@ -9924,7 +10024,7 @@
             <a:tbl>
               <a:tblPr>
                 <a:noFill/>
-                <a:tableStyleId>{458066C2-3691-4592-A9C5-7EF0F0C21B34}</a:tableStyleId>
+                <a:tableStyleId>{5F49613A-2DCC-4D57-9D93-BC7A9F9A7943}</a:tableStyleId>
               </a:tblPr>
               <a:tblGrid>
                 <a:gridCol w="710750"/>
@@ -11461,7 +11561,7 @@
             </a:pPr>
             <a:r>
               <a:rPr lang="en"/>
-              <a:t>Agenda</a:t>
+              <a:t>Agenda and references</a:t>
             </a:r>
             <a:endParaRPr/>
           </a:p>
@@ -11486,7 +11586,7 @@
         </p:spPr>
         <p:txBody>
           <a:bodyPr anchorCtr="0" anchor="t" bIns="91425" lIns="91425" spcFirstLastPara="1" rIns="91425" wrap="square" tIns="91425">
-            <a:normAutofit/>
+            <a:normAutofit fontScale="70000" lnSpcReduction="20000"/>
           </a:bodyPr>
           <a:lstStyle/>
           <a:p>
@@ -11501,19 +11601,37 @@
             </a:pPr>
             <a:r>
               <a:rPr lang="en"/>
+              <a:t>Agenda: </a:t>
+            </a:r>
+            <a:endParaRPr/>
+          </a:p>
+          <a:p>
+            <a:pPr indent="-308610" lvl="0" marL="457200" rtl="0" algn="l">
+              <a:spcBef>
+                <a:spcPts val="1200"/>
+              </a:spcBef>
+              <a:spcAft>
+                <a:spcPts val="0"/>
+              </a:spcAft>
+              <a:buSzPct val="100000"/>
+              <a:buChar char="●"/>
+            </a:pPr>
+            <a:r>
+              <a:rPr lang="en"/>
               <a:t>state-value function V</a:t>
             </a:r>
             <a:endParaRPr/>
           </a:p>
           <a:p>
-            <a:pPr indent="0" lvl="0" marL="0" rtl="0" algn="l">
-              <a:spcBef>
-                <a:spcPts val="1200"/>
-              </a:spcBef>
-              <a:spcAft>
-                <a:spcPts val="0"/>
-              </a:spcAft>
-              <a:buNone/>
+            <a:pPr indent="-308610" lvl="0" marL="457200" rtl="0" algn="l">
+              <a:spcBef>
+                <a:spcPts val="0"/>
+              </a:spcBef>
+              <a:spcAft>
+                <a:spcPts val="0"/>
+              </a:spcAft>
+              <a:buSzPct val="100000"/>
+              <a:buChar char="●"/>
             </a:pPr>
             <a:r>
               <a:rPr lang="en"/>
@@ -11522,14 +11640,15 @@
             <a:endParaRPr/>
           </a:p>
           <a:p>
-            <a:pPr indent="0" lvl="0" marL="0" rtl="0" algn="l">
-              <a:spcBef>
-                <a:spcPts val="1200"/>
-              </a:spcBef>
-              <a:spcAft>
-                <a:spcPts val="0"/>
-              </a:spcAft>
-              <a:buNone/>
+            <a:pPr indent="-308610" lvl="0" marL="457200" rtl="0" algn="l">
+              <a:spcBef>
+                <a:spcPts val="0"/>
+              </a:spcBef>
+              <a:spcAft>
+                <a:spcPts val="0"/>
+              </a:spcAft>
+              <a:buSzPct val="100000"/>
+              <a:buChar char="●"/>
             </a:pPr>
             <a:r>
               <a:rPr lang="en"/>
@@ -11538,14 +11657,15 @@
             <a:endParaRPr/>
           </a:p>
           <a:p>
-            <a:pPr indent="0" lvl="0" marL="0" rtl="0" algn="l">
-              <a:spcBef>
-                <a:spcPts val="1200"/>
-              </a:spcBef>
-              <a:spcAft>
-                <a:spcPts val="0"/>
-              </a:spcAft>
-              <a:buNone/>
+            <a:pPr indent="-308610" lvl="0" marL="457200" rtl="0" algn="l">
+              <a:spcBef>
+                <a:spcPts val="0"/>
+              </a:spcBef>
+              <a:spcAft>
+                <a:spcPts val="0"/>
+              </a:spcAft>
+              <a:buSzPct val="100000"/>
+              <a:buChar char="●"/>
             </a:pPr>
             <a:r>
               <a:rPr lang="en"/>
@@ -11554,14 +11674,15 @@
             <a:endParaRPr/>
           </a:p>
           <a:p>
-            <a:pPr indent="0" lvl="0" marL="0" rtl="0" algn="l">
-              <a:spcBef>
-                <a:spcPts val="1200"/>
-              </a:spcBef>
-              <a:spcAft>
-                <a:spcPts val="0"/>
-              </a:spcAft>
-              <a:buNone/>
+            <a:pPr indent="-308610" lvl="0" marL="457200" rtl="0" algn="l">
+              <a:spcBef>
+                <a:spcPts val="0"/>
+              </a:spcBef>
+              <a:spcAft>
+                <a:spcPts val="0"/>
+              </a:spcAft>
+              <a:buSzPct val="100000"/>
+              <a:buChar char="●"/>
             </a:pPr>
             <a:r>
               <a:rPr lang="en"/>
@@ -11570,18 +11691,110 @@
             <a:endParaRPr/>
           </a:p>
           <a:p>
-            <a:pPr indent="0" lvl="0" marL="0" rtl="0" algn="l">
-              <a:spcBef>
-                <a:spcPts val="1200"/>
-              </a:spcBef>
-              <a:spcAft>
-                <a:spcPts val="0"/>
-              </a:spcAft>
-              <a:buNone/>
+            <a:pPr indent="-308610" lvl="0" marL="457200" rtl="0" algn="l">
+              <a:spcBef>
+                <a:spcPts val="0"/>
+              </a:spcBef>
+              <a:spcAft>
+                <a:spcPts val="0"/>
+              </a:spcAft>
+              <a:buSzPct val="100000"/>
+              <a:buChar char="●"/>
             </a:pPr>
             <a:r>
               <a:rPr lang="en"/>
               <a:t>value iteration</a:t>
+            </a:r>
+            <a:endParaRPr/>
+          </a:p>
+          <a:p>
+            <a:pPr indent="0" lvl="0" marL="0" rtl="0" algn="l">
+              <a:spcBef>
+                <a:spcPts val="1200"/>
+              </a:spcBef>
+              <a:spcAft>
+                <a:spcPts val="0"/>
+              </a:spcAft>
+              <a:buNone/>
+            </a:pPr>
+            <a:r>
+              <a:rPr lang="en"/>
+              <a:t>References:</a:t>
+            </a:r>
+            <a:endParaRPr/>
+          </a:p>
+          <a:p>
+            <a:pPr indent="0" lvl="0" marL="0" rtl="0" algn="l">
+              <a:spcBef>
+                <a:spcPts val="1200"/>
+              </a:spcBef>
+              <a:spcAft>
+                <a:spcPts val="0"/>
+              </a:spcAft>
+              <a:buNone/>
+            </a:pPr>
+            <a:r>
+              <a:rPr lang="en" u="sng">
+                <a:solidFill>
+                  <a:schemeClr val="hlink"/>
+                </a:solidFill>
+                <a:hlinkClick r:id="rId3"/>
+              </a:rPr>
+              <a:t>https://spinningup.openai.com/en/latest/spinningup/rl_intro.html</a:t>
+            </a:r>
+            <a:endParaRPr/>
+          </a:p>
+          <a:p>
+            <a:pPr indent="0" lvl="0" marL="0" rtl="0" algn="l">
+              <a:spcBef>
+                <a:spcPts val="1200"/>
+              </a:spcBef>
+              <a:spcAft>
+                <a:spcPts val="0"/>
+              </a:spcAft>
+              <a:buNone/>
+            </a:pPr>
+            <a:r>
+              <a:rPr lang="en"/>
+              <a:t>David Silver lectures:</a:t>
+            </a:r>
+            <a:endParaRPr/>
+          </a:p>
+          <a:p>
+            <a:pPr indent="0" lvl="0" marL="0" rtl="0" algn="l">
+              <a:spcBef>
+                <a:spcPts val="1200"/>
+              </a:spcBef>
+              <a:spcAft>
+                <a:spcPts val="0"/>
+              </a:spcAft>
+              <a:buNone/>
+            </a:pPr>
+            <a:r>
+              <a:rPr lang="en"/>
+              <a:t>Lectures </a:t>
+            </a:r>
+            <a:r>
+              <a:rPr lang="en" u="sng">
+                <a:solidFill>
+                  <a:schemeClr val="hlink"/>
+                </a:solidFill>
+                <a:hlinkClick r:id="rId4"/>
+              </a:rPr>
+              <a:t>2</a:t>
+            </a:r>
+            <a:r>
+              <a:rPr lang="en"/>
+              <a:t> and </a:t>
+            </a:r>
+            <a:r>
+              <a:rPr lang="en" u="sng">
+                <a:solidFill>
+                  <a:schemeClr val="hlink"/>
+                </a:solidFill>
+                <a:hlinkClick r:id="rId5"/>
+              </a:rPr>
+              <a:t>3</a:t>
             </a:r>
             <a:endParaRPr/>
           </a:p>
@@ -12863,7 +13076,7 @@
             <a:tbl>
               <a:tblPr>
                 <a:noFill/>
-                <a:tableStyleId>{DC01734C-138F-4F08-94FE-1EE1B6B67373}</a:tableStyleId>
+                <a:tableStyleId>{DA5CA8FC-7503-4554-8BA5-C6196695F77C}</a:tableStyleId>
               </a:tblPr>
               <a:tblGrid>
                 <a:gridCol w="2929900"/>
@@ -12978,6 +13191,285 @@
 </file>
 
 <file path=ppt/theme/theme1.xml><?xml version="1.0" encoding="utf-8"?>
+<a:theme xmlns:a="http://schemas.openxmlformats.org/drawingml/2006/main" xmlns:r="http://schemas.openxmlformats.org/officeDocument/2006/relationships">
+  <a:themeElements>
+    <a:clrScheme name="Default">
+      <a:dk1>
+        <a:srgbClr val="000000"/>
+      </a:dk1>
+      <a:lt1>
+        <a:srgbClr val="FFFFFF"/>
+      </a:lt1>
+      <a:dk2>
+        <a:srgbClr val="158158"/>
+      </a:dk2>
+      <a:lt2>
+        <a:srgbClr val="F3F3F3"/>
+      </a:lt2>
+      <a:accent1>
+        <a:srgbClr val="058DC7"/>
+      </a:accent1>
+      <a:accent2>
+        <a:srgbClr val="50B432"/>
+      </a:accent2>
+      <a:accent3>
+        <a:srgbClr val="ED561B"/>
+      </a:accent3>
+      <a:accent4>
+        <a:srgbClr val="EDEF00"/>
+      </a:accent4>
+      <a:accent5>
+        <a:srgbClr val="24CBE5"/>
+      </a:accent5>
+      <a:accent6>
+        <a:srgbClr val="64E572"/>
+      </a:accent6>
+      <a:hlink>
+        <a:srgbClr val="2200CC"/>
+      </a:hlink>
+      <a:folHlink>
+        <a:srgbClr val="551A8B"/>
+      </a:folHlink>
+    </a:clrScheme>
+    <a:fontScheme name="Office">
+      <a:majorFont>
+        <a:latin typeface="Arial"/>
+        <a:ea typeface=""/>
+        <a:cs typeface=""/>
+        <a:font script="Jpan" typeface="ＭＳ Ｐゴシック"/>
+        <a:font script="Hang" typeface="맑은 고딕"/>
+        <a:font script="Hans" typeface="宋体"/>
+        <a:font script="Hant" typeface="新細明體"/>
+        <a:font script="Arab" typeface="Times New Roman"/>
+        <a:font script="Hebr" typeface="Times New Roman"/>
+        <a:font script="Thai" typeface="Angsana New"/>
+        <a:font script="Ethi" typeface="Nyala"/>
+        <a:font script="Beng" typeface="Vrinda"/>
+        <a:font script="Gujr" typeface="Shruti"/>
+        <a:font script="Khmr" typeface="MoolBoran"/>
+        <a:font script="Knda" typeface="Tunga"/>
+        <a:font script="Guru" typeface="Raavi"/>
+        <a:font script="Cans" typeface="Euphemia"/>
+        <a:font script="Cher" typeface="Plantagenet Cherokee"/>
+        <a:font script="Yiii" typeface="Microsoft Yi Baiti"/>
+        <a:font script="Tibt" typeface="Microsoft Himalaya"/>
+        <a:font script="Thaa" typeface="MV Boli"/>
+        <a:font script="Deva" typeface="Mangal"/>
+        <a:font script="Telu" typeface="Gautami"/>
+        <a:font script="Taml" typeface="Latha"/>
+        <a:font script="Syrc" typeface="Estrangelo Edessa"/>
+        <a:font script="Orya" typeface="Kalinga"/>
+        <a:font script="Mlym" typeface="Kartika"/>
+        <a:font script="Laoo" typeface="DokChampa"/>
+        <a:font script="Sinh" typeface="Iskoola Pota"/>
+        <a:font script="Mong" typeface="Mongolian Baiti"/>
+        <a:font script="Viet" typeface="Times New Roman"/>
+        <a:font script="Uigh" typeface="Microsoft Uighur"/>
+        <a:font script="Geor" typeface="Sylfaen"/>
+      </a:majorFont>
+      <a:minorFont>
+        <a:latin typeface="Arial"/>
+        <a:ea typeface=""/>
+        <a:cs typeface=""/>
+        <a:font script="Jpan" typeface="ＭＳ Ｐゴシック"/>
+        <a:font script="Hang" typeface="맑은 고딕"/>
+        <a:font script="Hans" typeface="宋体"/>
+        <a:font script="Hant" typeface="新細明體"/>
+        <a:font script="Arab" typeface="Arial"/>
+        <a:font script="Hebr" typeface="Arial"/>
+        <a:font script="Thai" typeface="Cordia New"/>
+        <a:font script="Ethi" typeface="Nyala"/>
+        <a:font script="Beng" typeface="Vrinda"/>
+        <a:font script="Gujr" typeface="Shruti"/>
+        <a:font script="Khmr" typeface="DaunPenh"/>
+        <a:font script="Knda" typeface="Tunga"/>
+        <a:font script="Guru" typeface="Raavi"/>
+        <a:font script="Cans" typeface="Euphemia"/>
+        <a:font script="Cher" typeface="Plantagenet Cherokee"/>
+        <a:font script="Yiii" typeface="Microsoft Yi Baiti"/>
+        <a:font script="Tibt" typeface="Microsoft Himalaya"/>
+        <a:font script="Thaa" typeface="MV Boli"/>
+        <a:font script="Deva" typeface="Mangal"/>
+        <a:font script="Telu" typeface="Gautami"/>
+        <a:font script="Taml" typeface="Latha"/>
+        <a:font script="Syrc" typeface="Estrangelo Edessa"/>
+        <a:font script="Orya" typeface="Kalinga"/>
+        <a:font script="Mlym" typeface="Kartika"/>
+        <a:font script="Laoo" typeface="DokChampa"/>
+        <a:font script="Sinh" typeface="Iskoola Pota"/>
+        <a:font script="Mong" typeface="Mongolian Baiti"/>
+        <a:font script="Viet" typeface="Arial"/>
+        <a:font script="Uigh" typeface="Microsoft Uighur"/>
+        <a:font script="Geor" typeface="Sylfaen"/>
+      </a:minorFont>
+    </a:fontScheme>
+    <a:fmtScheme name="Office">
+      <a:fillStyleLst>
+        <a:solidFill>
+          <a:schemeClr val="phClr"/>
+        </a:solidFill>
+        <a:gradFill rotWithShape="1">
+          <a:gsLst>
+            <a:gs pos="0">
+              <a:schemeClr val="phClr">
+                <a:tint val="50000"/>
+                <a:satMod val="300000"/>
+              </a:schemeClr>
+            </a:gs>
+            <a:gs pos="35000">
+              <a:schemeClr val="phClr">
+                <a:tint val="37000"/>
+                <a:satMod val="300000"/>
+              </a:schemeClr>
+            </a:gs>
+            <a:gs pos="100000">
+              <a:schemeClr val="phClr">
+                <a:tint val="15000"/>
+                <a:satMod val="350000"/>
+              </a:schemeClr>
+            </a:gs>
+          </a:gsLst>
+          <a:lin ang="16200000" scaled="1"/>
+        </a:gradFill>
+        <a:gradFill rotWithShape="1">
+          <a:gsLst>
+            <a:gs pos="0">
+              <a:schemeClr val="phClr">
+                <a:tint val="100000"/>
+                <a:shade val="100000"/>
+                <a:satMod val="130000"/>
+              </a:schemeClr>
+            </a:gs>
+            <a:gs pos="100000">
+              <a:schemeClr val="phClr">
+                <a:tint val="50000"/>
+                <a:shade val="100000"/>
+                <a:satMod val="350000"/>
+              </a:schemeClr>
+            </a:gs>
+          </a:gsLst>
+          <a:lin ang="16200000" scaled="0"/>
+        </a:gradFill>
+      </a:fillStyleLst>
+      <a:lnStyleLst>
+        <a:ln w="9525" cap="flat" cmpd="sng" algn="ctr">
+          <a:solidFill>
+            <a:schemeClr val="phClr">
+              <a:shade val="95000"/>
+              <a:satMod val="105000"/>
+            </a:schemeClr>
+          </a:solidFill>
+          <a:prstDash val="solid"/>
+        </a:ln>
+        <a:ln w="25400" cap="flat" cmpd="sng" algn="ctr">
+          <a:solidFill>
+            <a:schemeClr val="phClr"/>
+          </a:solidFill>
+          <a:prstDash val="solid"/>
+        </a:ln>
+        <a:ln w="38100" cap="flat" cmpd="sng" algn="ctr">
+          <a:solidFill>
+            <a:schemeClr val="phClr"/>
+          </a:solidFill>
+          <a:prstDash val="solid"/>
+        </a:ln>
+      </a:lnStyleLst>
+      <a:effectStyleLst>
+        <a:effectStyle>
+          <a:effectLst>
+            <a:outerShdw blurRad="40000" dist="20000" dir="5400000" rotWithShape="0">
+              <a:srgbClr val="000000">
+                <a:alpha val="38000"/>
+              </a:srgbClr>
+            </a:outerShdw>
+          </a:effectLst>
+        </a:effectStyle>
+        <a:effectStyle>
+          <a:effectLst>
+            <a:outerShdw blurRad="40000" dist="23000" dir="5400000" rotWithShape="0">
+              <a:srgbClr val="000000">
+                <a:alpha val="35000"/>
+              </a:srgbClr>
+            </a:outerShdw>
+          </a:effectLst>
+        </a:effectStyle>
+        <a:effectStyle>
+          <a:effectLst>
+            <a:outerShdw blurRad="40000" dist="23000" dir="5400000" rotWithShape="0">
+              <a:srgbClr val="000000">
+                <a:alpha val="35000"/>
+              </a:srgbClr>
+            </a:outerShdw>
+          </a:effectLst>
+          <a:scene3d>
+            <a:camera prst="orthographicFront">
+              <a:rot lat="0" lon="0" rev="0"/>
+            </a:camera>
+            <a:lightRig rig="threePt" dir="t">
+              <a:rot lat="0" lon="0" rev="1200000"/>
+            </a:lightRig>
+          </a:scene3d>
+          <a:sp3d>
+            <a:bevelT w="63500" h="25400"/>
+          </a:sp3d>
+        </a:effectStyle>
+      </a:effectStyleLst>
+      <a:bgFillStyleLst>
+        <a:solidFill>
+          <a:schemeClr val="phClr"/>
+        </a:solidFill>
+        <a:gradFill rotWithShape="1">
+          <a:gsLst>
+            <a:gs pos="0">
+              <a:schemeClr val="phClr">
+                <a:tint val="40000"/>
+                <a:satMod val="350000"/>
+              </a:schemeClr>
+            </a:gs>
+            <a:gs pos="40000">
+              <a:schemeClr val="phClr">
+                <a:tint val="45000"/>
+                <a:shade val="99000"/>
+                <a:satMod val="350000"/>
+              </a:schemeClr>
+            </a:gs>
+            <a:gs pos="100000">
+              <a:schemeClr val="phClr">
+                <a:shade val="20000"/>
+                <a:satMod val="255000"/>
+              </a:schemeClr>
+            </a:gs>
+          </a:gsLst>
+          <a:path path="circle">
+            <a:fillToRect l="50000" t="-80000" r="50000" b="180000"/>
+          </a:path>
+        </a:gradFill>
+        <a:gradFill rotWithShape="1">
+          <a:gsLst>
+            <a:gs pos="0">
+              <a:schemeClr val="phClr">
+                <a:tint val="80000"/>
+                <a:satMod val="300000"/>
+              </a:schemeClr>
+            </a:gs>
+            <a:gs pos="100000">
+              <a:schemeClr val="phClr">
+                <a:shade val="30000"/>
+                <a:satMod val="200000"/>
+              </a:schemeClr>
+            </a:gs>
+          </a:gsLst>
+          <a:path path="circle">
+            <a:fillToRect l="50000" t="50000" r="50000" b="50000"/>
+          </a:path>
+        </a:gradFill>
+      </a:bgFillStyleLst>
+    </a:fmtScheme>
+  </a:themeElements>
+</a:theme>
+</file>
+
+<file path=ppt/theme/theme2.xml><?xml version="1.0" encoding="utf-8"?>
 <a:theme xmlns:a="http://schemas.openxmlformats.org/drawingml/2006/main" xmlns:r="http://schemas.openxmlformats.org/officeDocument/2006/relationships" name="Simple Light">
   <a:themeElements>
     <a:clrScheme name="Simple Light">
@@ -13254,283 +13746,4 @@
     </a:fmtScheme>
   </a:themeElements>
 </a:theme>
-</file>
-
-<file path=ppt/theme/theme2.xml><?xml version="1.0" encoding="utf-8"?>
-<a:theme xmlns:a="http://schemas.openxmlformats.org/drawingml/2006/main" xmlns:r="http://schemas.openxmlformats.org/officeDocument/2006/relationships">
-  <a:themeElements>
-    <a:clrScheme name="Default">
-      <a:dk1>
-        <a:srgbClr val="000000"/>
-      </a:dk1>
-      <a:lt1>
-        <a:srgbClr val="FFFFFF"/>
-      </a:lt1>
-      <a:dk2>
-        <a:srgbClr val="158158"/>
-      </a:dk2>
-      <a:lt2>
-        <a:srgbClr val="F3F3F3"/>
-      </a:lt2>
-      <a:accent1>
-        <a:srgbClr val="058DC7"/>
-      </a:accent1>
-      <a:accent2>
-        <a:srgbClr val="50B432"/>
-      </a:accent2>
-      <a:accent3>
-        <a:srgbClr val="ED561B"/>
-      </a:accent3>
-      <a:accent4>
-        <a:srgbClr val="EDEF00"/>
-      </a:accent4>
-      <a:accent5>
-        <a:srgbClr val="24CBE5"/>
-      </a:accent5>
-      <a:accent6>
-        <a:srgbClr val="64E572"/>
-      </a:accent6>
-      <a:hlink>
-        <a:srgbClr val="2200CC"/>
-      </a:hlink>
-      <a:folHlink>
-        <a:srgbClr val="551A8B"/>
-      </a:folHlink>
-    </a:clrScheme>
-    <a:fontScheme name="Office">
-      <a:majorFont>
-        <a:latin typeface="Arial"/>
-        <a:ea typeface=""/>
-        <a:cs typeface=""/>
-        <a:font script="Jpan" typeface="ＭＳ Ｐゴシック"/>
-        <a:font script="Hang" typeface="맑은 고딕"/>
-        <a:font script="Hans" typeface="宋体"/>
-        <a:font script="Hant" typeface="新細明體"/>
-        <a:font script="Arab" typeface="Times New Roman"/>
-        <a:font script="Hebr" typeface="Times New Roman"/>
-        <a:font script="Thai" typeface="Angsana New"/>
-        <a:font script="Ethi" typeface="Nyala"/>
-        <a:font script="Beng" typeface="Vrinda"/>
-        <a:font script="Gujr" typeface="Shruti"/>
-        <a:font script="Khmr" typeface="MoolBoran"/>
-        <a:font script="Knda" typeface="Tunga"/>
-        <a:font script="Guru" typeface="Raavi"/>
-        <a:font script="Cans" typeface="Euphemia"/>
-        <a:font script="Cher" typeface="Plantagenet Cherokee"/>
-        <a:font script="Yiii" typeface="Microsoft Yi Baiti"/>
-        <a:font script="Tibt" typeface="Microsoft Himalaya"/>
-        <a:font script="Thaa" typeface="MV Boli"/>
-        <a:font script="Deva" typeface="Mangal"/>
-        <a:font script="Telu" typeface="Gautami"/>
-        <a:font script="Taml" typeface="Latha"/>
-        <a:font script="Syrc" typeface="Estrangelo Edessa"/>
-        <a:font script="Orya" typeface="Kalinga"/>
-        <a:font script="Mlym" typeface="Kartika"/>
-        <a:font script="Laoo" typeface="DokChampa"/>
-        <a:font script="Sinh" typeface="Iskoola Pota"/>
-        <a:font script="Mong" typeface="Mongolian Baiti"/>
-        <a:font script="Viet" typeface="Times New Roman"/>
-        <a:font script="Uigh" typeface="Microsoft Uighur"/>
-        <a:font script="Geor" typeface="Sylfaen"/>
-      </a:majorFont>
-      <a:minorFont>
-        <a:latin typeface="Arial"/>
-        <a:ea typeface=""/>
-        <a:cs typeface=""/>
-        <a:font script="Jpan" typeface="ＭＳ Ｐゴシック"/>
-        <a:font script="Hang" typeface="맑은 고딕"/>
-        <a:font script="Hans" typeface="宋体"/>
-        <a:font script="Hant" typeface="新細明體"/>
-        <a:font script="Arab" typeface="Arial"/>
-        <a:font script="Hebr" typeface="Arial"/>
-        <a:font script="Thai" typeface="Cordia New"/>
-        <a:font script="Ethi" typeface="Nyala"/>
-        <a:font script="Beng" typeface="Vrinda"/>
-        <a:font script="Gujr" typeface="Shruti"/>
-        <a:font script="Khmr" typeface="DaunPenh"/>
-        <a:font script="Knda" typeface="Tunga"/>
-        <a:font script="Guru" typeface="Raavi"/>
-        <a:font script="Cans" typeface="Euphemia"/>
-        <a:font script="Cher" typeface="Plantagenet Cherokee"/>
-        <a:font script="Yiii" typeface="Microsoft Yi Baiti"/>
-        <a:font script="Tibt" typeface="Microsoft Himalaya"/>
-        <a:font script="Thaa" typeface="MV Boli"/>
-        <a:font script="Deva" typeface="Mangal"/>
-        <a:font script="Telu" typeface="Gautami"/>
-        <a:font script="Taml" typeface="Latha"/>
-        <a:font script="Syrc" typeface="Estrangelo Edessa"/>
-        <a:font script="Orya" typeface="Kalinga"/>
-        <a:font script="Mlym" typeface="Kartika"/>
-        <a:font script="Laoo" typeface="DokChampa"/>
-        <a:font script="Sinh" typeface="Iskoola Pota"/>
-        <a:font script="Mong" typeface="Mongolian Baiti"/>
-        <a:font script="Viet" typeface="Arial"/>
-        <a:font script="Uigh" typeface="Microsoft Uighur"/>
-        <a:font script="Geor" typeface="Sylfaen"/>
-      </a:minorFont>
-    </a:fontScheme>
-    <a:fmtScheme name="Office">
-      <a:fillStyleLst>
-        <a:solidFill>
-          <a:schemeClr val="phClr"/>
-        </a:solidFill>
-        <a:gradFill rotWithShape="1">
-          <a:gsLst>
-            <a:gs pos="0">
-              <a:schemeClr val="phClr">
-                <a:tint val="50000"/>
-                <a:satMod val="300000"/>
-              </a:schemeClr>
-            </a:gs>
-            <a:gs pos="35000">
-              <a:schemeClr val="phClr">
-                <a:tint val="37000"/>
-                <a:satMod val="300000"/>
-              </a:schemeClr>
-            </a:gs>
-            <a:gs pos="100000">
-              <a:schemeClr val="phClr">
-                <a:tint val="15000"/>
-                <a:satMod val="350000"/>
-              </a:schemeClr>
-            </a:gs>
-          </a:gsLst>
-          <a:lin ang="16200000" scaled="1"/>
-        </a:gradFill>
-        <a:gradFill rotWithShape="1">
-          <a:gsLst>
-            <a:gs pos="0">
-              <a:schemeClr val="phClr">
-                <a:tint val="100000"/>
-                <a:shade val="100000"/>
-                <a:satMod val="130000"/>
-              </a:schemeClr>
-            </a:gs>
-            <a:gs pos="100000">
-              <a:schemeClr val="phClr">
-                <a:tint val="50000"/>
-                <a:shade val="100000"/>
-                <a:satMod val="350000"/>
-              </a:schemeClr>
-            </a:gs>
-          </a:gsLst>
-          <a:lin ang="16200000" scaled="0"/>
-        </a:gradFill>
-      </a:fillStyleLst>
-      <a:lnStyleLst>
-        <a:ln w="9525" cap="flat" cmpd="sng" algn="ctr">
-          <a:solidFill>
-            <a:schemeClr val="phClr">
-              <a:shade val="95000"/>
-              <a:satMod val="105000"/>
-            </a:schemeClr>
-          </a:solidFill>
-          <a:prstDash val="solid"/>
-        </a:ln>
-        <a:ln w="25400" cap="flat" cmpd="sng" algn="ctr">
-          <a:solidFill>
-            <a:schemeClr val="phClr"/>
-          </a:solidFill>
-          <a:prstDash val="solid"/>
-        </a:ln>
-        <a:ln w="38100" cap="flat" cmpd="sng" algn="ctr">
-          <a:solidFill>
-            <a:schemeClr val="phClr"/>
-          </a:solidFill>
-          <a:prstDash val="solid"/>
-        </a:ln>
-      </a:lnStyleLst>
-      <a:effectStyleLst>
-        <a:effectStyle>
-          <a:effectLst>
-            <a:outerShdw blurRad="40000" dist="20000" dir="5400000" rotWithShape="0">
-              <a:srgbClr val="000000">
-                <a:alpha val="38000"/>
-              </a:srgbClr>
-            </a:outerShdw>
-          </a:effectLst>
-        </a:effectStyle>
-        <a:effectStyle>
-          <a:effectLst>
-            <a:outerShdw blurRad="40000" dist="23000" dir="5400000" rotWithShape="0">
-              <a:srgbClr val="000000">
-                <a:alpha val="35000"/>
-              </a:srgbClr>
-            </a:outerShdw>
-          </a:effectLst>
-        </a:effectStyle>
-        <a:effectStyle>
-          <a:effectLst>
-            <a:outerShdw blurRad="40000" dist="23000" dir="5400000" rotWithShape="0">
-              <a:srgbClr val="000000">
-                <a:alpha val="35000"/>
-              </a:srgbClr>
-            </a:outerShdw>
-          </a:effectLst>
-          <a:scene3d>
-            <a:camera prst="orthographicFront">
-              <a:rot lat="0" lon="0" rev="0"/>
-            </a:camera>
-            <a:lightRig rig="threePt" dir="t">
-              <a:rot lat="0" lon="0" rev="1200000"/>
-            </a:lightRig>
-          </a:scene3d>
-          <a:sp3d>
-            <a:bevelT w="63500" h="25400"/>
-          </a:sp3d>
-        </a:effectStyle>
-      </a:effectStyleLst>
-      <a:bgFillStyleLst>
-        <a:solidFill>
-          <a:schemeClr val="phClr"/>
-        </a:solidFill>
-        <a:gradFill rotWithShape="1">
-          <a:gsLst>
-            <a:gs pos="0">
-              <a:schemeClr val="phClr">
-                <a:tint val="40000"/>
-                <a:satMod val="350000"/>
-              </a:schemeClr>
-            </a:gs>
-            <a:gs pos="40000">
-              <a:schemeClr val="phClr">
-                <a:tint val="45000"/>
-                <a:shade val="99000"/>
-                <a:satMod val="350000"/>
-              </a:schemeClr>
-            </a:gs>
-            <a:gs pos="100000">
-              <a:schemeClr val="phClr">
-                <a:shade val="20000"/>
-                <a:satMod val="255000"/>
-              </a:schemeClr>
-            </a:gs>
-          </a:gsLst>
-          <a:path path="circle">
-            <a:fillToRect l="50000" t="-80000" r="50000" b="180000"/>
-          </a:path>
-        </a:gradFill>
-        <a:gradFill rotWithShape="1">
-          <a:gsLst>
-            <a:gs pos="0">
-              <a:schemeClr val="phClr">
-                <a:tint val="80000"/>
-                <a:satMod val="300000"/>
-              </a:schemeClr>
-            </a:gs>
-            <a:gs pos="100000">
-              <a:schemeClr val="phClr">
-                <a:shade val="30000"/>
-                <a:satMod val="200000"/>
-              </a:schemeClr>
-            </a:gs>
-          </a:gsLst>
-          <a:path path="circle">
-            <a:fillToRect l="50000" t="50000" r="50000" b="50000"/>
-          </a:path>
-        </a:gradFill>
-      </a:bgFillStyleLst>
-    </a:fmtScheme>
-  </a:themeElements>
-</a:theme>
 </file>
</xml_diff>